<commit_message>
docs(presentations): give slide 2 a job the rest of the deck discharges
Slide 2 described the corpus and then handed off with a promise ("everything
after this slide is about reading it") that slide 3 did not cash. It was the
only slide in the deck nothing downstream referred back to, and the 6.5M
action notes appeared there and then vanished until slide 6, which is where
the deck felt like it swerved.

Slide 2 is now the map. Its three rows are the citizen's text, the officer's
notes, and the fact that the portal has opened neither, and it closes on a
claim the rest of the deck discharges rather than a table-setting line. The
eyebrows mark the branch: slide 3 opens the first body, slide 6 opens the
second, so the closure finding arrives as the announced turn.

Also export SPEAKER_NOTES.md from the deck on every build. It was hand-written
and had already drifted from the notes in the script.
</commit_message>
<xml_diff>
--- a/docs/presentations/2026-08-24-timing-quality/Janasunani_2.0_Timing_and_Quality.pptx
+++ b/docs/presentations/2026-08-24-timing-quality/Janasunani_2.0_Timing_and_Quality.pptx
@@ -341,13 +341,13 @@
           <a:p/>
           <a:p>
             <a:r>
-              <a:t>Two structural facts drive the whole deck. The portal has never read what the citizen wrote. And there is no citizen key, so every row is an island, which is why deduplication on the next slide needs the whole corpus at once.</a:t>
+              <a:t>THIS SLIDE IS THE MAP. Two bodies of free text, and the deck reads them in that order. Slides 3 to 5 read the citizen's text: the stages, their speed and quality, and the department suggestion. Slides 6 and 7 read the officer's notes: how closures are recorded, and whether a different route would have closed cases faster. Say the two halves out loud here, so slide 6 lands as the turn rather than a new topic.</a:t>
             </a:r>
           </a:p>
           <a:p/>
           <a:p>
             <a:r>
-              <a:t>This slide used to carry a closure breakdown. That data now sits on slide 6, where it belongs, because it is the reason the routing model needed a correctness constraint.</a:t>
+              <a:t>The third row is the reason the project exists. The portal has never opened either body of text. There is also no citizen key, so every row is an island, which is why deduplication on the next slide needs the whole corpus at once.</a:t>
             </a:r>
           </a:p>
         </p:txBody>
@@ -713,7 +713,13 @@
           <a:lstStyle/>
           <a:p>
             <a:r>
-              <a:t>This slide exists to set up the next one. It is also the strongest finding in the record.</a:t>
+              <a:t>THIS IS THE TURN slide 2 announced. Everything up to here read the citizen's text. From here the source is the officer's action notes, the second of the two bodies. Say so; it is one sentence and it stops this slide reading as a new topic.</a:t>
+            </a:r>
+          </a:p>
+          <a:p/>
+          <a:p>
+            <a:r>
+              <a:t>It sets up the next slide and it is also the strongest finding in the record.</a:t>
             </a:r>
           </a:p>
           <a:p/>
@@ -1946,7 +1952,7 @@
                 <a:ea typeface="Calibri" pitchFamily="34" charset="-122"/>
                 <a:cs typeface="Calibri" pitchFamily="34" charset="-120"/>
               </a:rPr>
-              <a:t>Filed between 2021 and 2025, across 30 districts and 427 blocks.</a:t>
+              <a:t>What the citizen asked for, 2021 to 2025 across 30 districts. Median 19 words, mostly unique.</a:t>
             </a:r>
             <a:endParaRPr lang="en-US" sz="1900" dirty="0"/>
           </a:p>
@@ -2054,7 +2060,7 @@
                 <a:ea typeface="Calibri" pitchFamily="34" charset="-122"/>
                 <a:cs typeface="Calibri" pitchFamily="34" charset="-120"/>
               </a:rPr>
-              <a:t>Every step an officer took on a case, written as free text.</a:t>
+              <a:t>What the officer did about it. Free text on 99.87% of rows, 1.4 million distinct values.</a:t>
             </a:r>
             <a:endParaRPr lang="en-US" sz="1900" dirty="0"/>
           </a:p>
@@ -2120,7 +2126,7 @@
                 <a:ea typeface="Cambria" pitchFamily="34" charset="-122"/>
                 <a:cs typeface="Cambria" pitchFamily="34" charset="-120"/>
               </a:rPr>
-              <a:t>Counts only</a:t>
+              <a:t>The portal counts rows</a:t>
             </a:r>
             <a:endParaRPr lang="en-US" sz="2100" dirty="0"/>
           </a:p>
@@ -2162,7 +2168,7 @@
                 <a:ea typeface="Calibri" pitchFamily="34" charset="-122"/>
                 <a:cs typeface="Calibri" pitchFamily="34" charset="-120"/>
               </a:rPr>
-              <a:t>The portal reports how many cases are open and how many are closed. It has never opened either body of text.</a:t>
+              <a:t>It reports how many cases are open and how many are closed. It has never opened either body of text.</a:t>
             </a:r>
             <a:endParaRPr lang="en-US" sz="1900" dirty="0"/>
           </a:p>
@@ -2276,7 +2282,7 @@
                 </a:solidFill>
                 <a:latin typeface="Calibri"/>
               </a:rPr>
-              <a:t>Everything after this slide is about reading it.</a:t>
+              <a:t>Every number in this deck comes from reading one of those two.</a:t>
             </a:r>
           </a:p>
         </p:txBody>
@@ -2332,7 +2338,7 @@
                 <a:ea typeface="Calibri" pitchFamily="34" charset="-122"/>
                 <a:cs typeface="Calibri" pitchFamily="34" charset="-120"/>
               </a:rPr>
-              <a:t>HOW IT WORKS</a:t>
+              <a:t>READING THE CITIZEN'S TEXT</a:t>
             </a:r>
             <a:endParaRPr lang="en-US" sz="1500" dirty="0"/>
           </a:p>
@@ -4526,7 +4532,7 @@
                 <a:ea typeface="Calibri" pitchFamily="34" charset="-122"/>
                 <a:cs typeface="Calibri" pitchFamily="34" charset="-120"/>
               </a:rPr>
-              <a:t>WHAT CLOSURE RECORDS</a:t>
+              <a:t>READING THE OFFICER'S NOTES</a:t>
             </a:r>
             <a:endParaRPr lang="en-US" sz="1500" dirty="0"/>
           </a:p>

</xml_diff>

<commit_message>
docs(presentations): stop slide 8 and slide 4 overflowing their bounds
Rendered and read the JPEGs rather than trusting the build. Two shapes
were over their bounds:

Slide 8, items 2 and 3 ran to four lines in a three-line grey box, so
the last line sat on the border. Both are cut to roughly the length that
fits, and item 2 now uses the repo's own framing: a campaign and two
hundred separate problems count the same.

Slide 4 gained a third footnote when the provenance line landed, and the
stack reached y=7.00 where the footer lockup sits. The three notes move
up to 6.20 / 6.43 / 6.66.

Copy only, no figures changed.
</commit_message>
<xml_diff>
--- a/docs/presentations/2026-08-24-timing-quality/Janasunani_2.0_Timing_and_Quality.pptx
+++ b/docs/presentations/2026-08-24-timing-quality/Janasunani_2.0_Timing_and_Quality.pptx
@@ -4077,7 +4077,7 @@
         </p:nvSpPr>
         <p:spPr>
           <a:xfrm>
-            <a:off x="640080" y="5742432"/>
+            <a:off x="640080" y="5669280"/>
             <a:ext cx="10881360" cy="237744"/>
           </a:xfrm>
           <a:prstGeom prst="rect">
@@ -4112,7 +4112,7 @@
         </p:nvSpPr>
         <p:spPr>
           <a:xfrm>
-            <a:off x="640080" y="5961888"/>
+            <a:off x="640080" y="5879592"/>
             <a:ext cx="10881360" cy="237744"/>
           </a:xfrm>
           <a:prstGeom prst="rect">
@@ -4147,7 +4147,7 @@
         </p:nvSpPr>
         <p:spPr>
           <a:xfrm>
-            <a:off x="640080" y="6199632"/>
+            <a:off x="640080" y="6089904"/>
             <a:ext cx="10881360" cy="201168"/>
           </a:xfrm>
           <a:prstGeom prst="rect">
@@ -6781,7 +6781,7 @@
                 <a:ea typeface="Calibri" pitchFamily="34" charset="-122"/>
                 <a:cs typeface="Calibri" pitchFamily="34" charset="-120"/>
               </a:rPr>
-              <a:t>Every spike carries filings, distinct problems and distinct citizens. Four hundred citizens on one road and two hundred unrelated problems look identical in a count.</a:t>
+              <a:t>Every spike carries filings, distinct problems and distinct citizens. A campaign and two hundred separate problems count the same.</a:t>
             </a:r>
             <a:endParaRPr lang="en-US" sz="1450" dirty="0"/>
           </a:p>
@@ -6968,7 +6968,7 @@
                 <a:ea typeface="Calibri" pitchFamily="34" charset="-122"/>
                 <a:cs typeface="Calibri" pitchFamily="34" charset="-120"/>
               </a:rPr>
-              <a:t>Grouped by what complaints are about rather than the category assigned at intake. Concentrated in one place and rising is the alert worth acting on.</a:t>
+              <a:t>Grouped by what complaints are about, not the category assigned at intake. Concentrated in one place and rising is the alert worth acting on.</a:t>
             </a:r>
             <a:endParaRPr lang="en-US" sz="1450" dirty="0"/>
           </a:p>

</xml_diff>